<commit_message>
Deck Python: pergunta grupu jerál ba staf organizasaun hotu (KSI, FONGTIL, RbR)
Co-Authored-By: Claude Opus 5.5 <noreply@anthropic.com>
Claude-Session: https://claude.ai/code/session_015hRiA8rRvASEHdtmFcc2JC
</commit_message>
<xml_diff>
--- a/docs/formasaun/RbR_Sesaun_Python_SIBAR-RbR.pptx
+++ b/docs/formasaun/RbR_Sesaun_Python_SIBAR-RbR.pptx
@@ -147,7 +147,7 @@
   <p:extLst>
     <p:ext uri="{521415D9-36F7-43E2-AB2F-B90AF26B5E84}">
       <p14:sectionLst xmlns:p14="http://schemas.microsoft.com/office/powerpoint/2010/main">
-        <p14:section name="Introdusaun" id="{6fc481f0-b05a-5677-be1e-60426ed65bc5}">
+        <p14:section name="Introdusaun" id="{3e8eb270-9132-f480-33f1-7c7afdd16e55}">
           <p14:sldIdLst>
             <p14:sldId id="256"/>
             <p14:sldId id="257"/>
@@ -155,7 +155,7 @@
             <p14:sldId id="259"/>
           </p14:sldIdLst>
         </p14:section>
-        <p14:section name="Saida mak Python" id="{f52e3740-2865-605e-4e09-27d0ffc36e66}">
+        <p14:section name="Saida mak Python" id="{8436abca-001f-8079-55e8-d115a03f675a}">
           <p14:sldIdLst>
             <p14:sldId id="260"/>
             <p14:sldId id="261"/>
@@ -164,7 +164,7 @@
             <p14:sldId id="264"/>
           </p14:sldIdLst>
         </p14:section>
-        <p14:section name="Istória Python" id="{f1576378-9f93-24f3-d9d2-5ded00981394}">
+        <p14:section name="Istória Python" id="{53b6186e-6d92-a846-d102-770a36d4bf88}">
           <p14:sldIdLst>
             <p14:sldId id="265"/>
             <p14:sldId id="266"/>
@@ -174,7 +174,7 @@
             <p14:sldId id="270"/>
           </p14:sldIdLst>
         </p14:section>
-        <p14:section name="Tanba sá Python" id="{1e662323-a5ed-ecba-2bc0-294a92c07bd4}">
+        <p14:section name="Tanba sá Python" id="{2b9ba412-eac5-eb7d-b083-ea949ab0e1d4}">
           <p14:sldIdLst>
             <p14:sldId id="271"/>
             <p14:sldId id="272"/>
@@ -182,7 +182,7 @@
             <p14:sldId id="274"/>
           </p14:sldIdLst>
         </p14:section>
-        <p14:section name="Python iha RbR" id="{686f8348-5feb-fdc3-c09d-dc0ab434d0fe}">
+        <p14:section name="Python iha RbR" id="{32783997-5963-dbce-b0d6-cb6c034f73bd}">
           <p14:sldIdLst>
             <p14:sldId id="275"/>
             <p14:sldId id="276"/>
@@ -190,7 +190,7 @@
             <p14:sldId id="278"/>
           </p14:sldIdLst>
         </p14:section>
-        <p14:section name="Kódigu no Live" id="{c3314644-c13e-bf46-15b9-8617c90c9bb0}">
+        <p14:section name="Kódigu no Live" id="{36e1b6df-dbe7-c2c2-8287-ed14e47bf7c2}">
           <p14:sldIdLst>
             <p14:sldId id="279"/>
             <p14:sldId id="280"/>
@@ -199,14 +199,14 @@
             <p14:sldId id="283"/>
           </p14:sldIdLst>
         </p14:section>
-        <p14:section name="Futuru" id="{5c38bcd2-dc2d-d08d-b745-715a13360c21}">
+        <p14:section name="Futuru" id="{ae88e044-e840-1413-f1c7-c8b5a5f9f706}">
           <p14:sldIdLst>
             <p14:sldId id="284"/>
             <p14:sldId id="285"/>
             <p14:sldId id="286"/>
           </p14:sldIdLst>
         </p14:section>
-        <p14:section name="Perguntas" id="{a363fa8d-fa90-16aa-2e30-8a75d8ab8bdd}">
+        <p14:section name="Perguntas" id="{adbef65a-d4b1-0770-712a-1a34cbfd60a6}">
           <p14:sldIdLst>
             <p14:sldId id="287"/>
             <p14:sldId id="288"/>
@@ -2920,7 +2920,7 @@
           <a:p>
             <a:r>
               <a:rPr lang="en-US" dirty="0"/>
-              <a:t>[11:43 – 1 min] Fahe partisipante ba grupu 5 (kontagem 1–5 ka tuir mesa). Kada grupu hili porta-voz. Grupu ida-idak simu kartaun pergunta (imprime husi Kartaun_Grupu PDF). Diskute minutu 5, depois kada grupu aprezenta minutu 1. Hatete: la iha resposta sala, ita hakarak rona imi-nia hanoin.</a:t>
+              <a:t>[11:43 – 1 min] Fahe partisipante ba grupu 5: kahur organizasaun (KSI, FONGTIL, RbR no seluk) iha kada grupu, kontagem 1–5. Kada grupu hili porta-voz. Grupu ida-idak simu kartaun pergunta (imprime husi Kartaun_Grupu PDF). Diskute minutu 5, depois kada grupu aprezenta minutu 1. Hatete: la iha resposta sala, ita hakarak rona imi-nia hanoin.</a:t>
             </a:r>
             <a:endParaRPr lang="en-US" dirty="0"/>
           </a:p>
@@ -3097,7 +3097,7 @@
             <a:r>
               <a:rPr lang="en-US" dirty="0"/>
               <a:t>[11:49 – 1 min] Porta-voz Grupu 1 aprezenta. Hafoin, agradese no aumenta ideia ida se presiza.
-Resposta ezemplu: (1) 'Python mak lian atu fó ordem ba komputadór, hanesan ita fó instrusaun ba ema.' (2) Se eviksaun akontese ona (Sin), komputadór hatudu 'Kazu urjente!'. Se Lae, la hatudu buat ida. (3) Ezemplu: konta kazu kada fulan ba relatóriu, kombina Excel husi munisípiu, buka kazu duplikadu, kalkula uma-kain afetadu.</a:t>
+Resposta ezemplu: (1) 'Python mak lian atu fó ordem ba komputadór, hanesan ita fó instrusaun ba ema.' (2) Se partisipante liu 30, komputadór hakerek 'Sala la to'o!'; se 30 ka menus, la hatudu buat ida. (3) Ezemplu: kombina lista partisipante husi Excel barak, konta benefisiáriu tuir munisípiu no seksu, halo relatóriu fulan ba doadór, haruka email lembrete automátiku, hamoos naran duplikadu.</a:t>
             </a:r>
             <a:endParaRPr lang="en-US" dirty="0"/>
           </a:p>
@@ -3186,7 +3186,7 @@
             <a:r>
               <a:rPr lang="en-US" dirty="0"/>
               <a:t>[11:50 – 1 min] Porta-voz Grupu 2 aprezenta. Hafoin, agradese no aumenta ideia ida se presiza.
-Resposta ezemplu: (1) Husi programa komédia BBC 'Monty Python's Flying Circus', la'ós husi samea. (2) Buat boot bele hahú ki'ik; ideia ida + persisténsia; ema ida bele muda mundu. (3) La selu lisensa (osan ba programa), la depende ba kompañia ida, ema barak bele ajuda, seguru tanba komunidade haree no hadi'a.</a:t>
+Resposta ezemplu: (1) Husi programa komédia BBC 'Monty Python's Flying Circus', la'ós husi samea. Naran badak no fásil hanoin. (2) Ezemplu: formuláriu online simples ba rekolla dadus, baze dadus membru, grupu aprende tekonolojia; buat boot hahú ki'ik ho persisténsia. (3) La selu lisensa; osan bele uza ba programa komunidade; la depende ba kompañia ida; komunidade mundu ajuda; staf bele aprende gratuitu online.</a:t>
             </a:r>
             <a:endParaRPr lang="en-US" dirty="0"/>
           </a:p>
@@ -3275,7 +3275,7 @@
             <a:r>
               <a:rPr lang="en-US" dirty="0"/>
               <a:t>[11:51 – 1 min] Porta-voz Grupu 3 aprezenta. Hafoin, agradese no aumenta ideia ida se presiza.
-Resposta ezemplu: (1) Dokumentu lakon, versaun Excel barak, susar buka kazu, relatóriu manuál naruk. (2) Di'ak: buka lalais, mapa, app offline, relatóriu automátiku. Susar: aprende sistema foun, sinál internet. (3) Númeru sala (kazu barak liu loloos), governu ka doadór la fiar dadus, rekursu sala fatin. Tan ne'e SIBAR-RbR agora iha ID HP automátiku no avizu 'posivel duplikadu'.</a:t>
+Resposta ezemplu: (1) Dadus iha komputadór ema ida, versaun barak, susar buka, lakon bainhira staf sai. (2) Lista partisipante formasaun, avaliasaun, dadus benefisiáriu: rekolla maibé la analiza. (3) Benefísiu: evita servisu dala rua, haree kuadru nasionál, advokasia hamutuk forte. Risku: privasidade ema, dadus sensível sai, la iha akordu; presiza regra no konsentimentu.</a:t>
             </a:r>
             <a:endParaRPr lang="en-US" dirty="0"/>
           </a:p>
@@ -3364,7 +3364,7 @@
             <a:r>
               <a:rPr lang="en-US" dirty="0"/>
               <a:t>[11:52 – 1 min] Porta-voz Grupu 4 aprezenta. Hafoin, agradese no aumenta ideia ida se presiza.
-Resposta ezemplu: (1) Kazu eviksaun la iha konsultasaun molok; uma-kain afetadu; kazu urjente: hatudu impaktu loos. (2) Ezemplu: 'Munisípiu ida-ne'ebé kazu eviksaun sa'e liu iha tinan ida-ne'e?', 'Kazu hira mak entidade governu foti rai?'. (3) Evidénsia ba diálogu ho governu, relatóriu ba parlamentu no doadór, prioridade apoiu legál ba kazu urjente.</a:t>
+Resposta ezemplu: (1) Benefisiáriu tuir seksu/idade/munisípiu, atividade hira, osan uza; halo lalais ho Excel di'ak ka Python automátiku. (2) Mapa problema tuir munisípiu, gráfiku tendénsia tinan ba tinan, komparasaun feto/mane. (3) Hili prioridade fatin ne'ebé presiza liu, fó evidénsia ba diálogu ho governu, fila fali rezultadu ba komunidade.</a:t>
             </a:r>
             <a:endParaRPr lang="en-US" dirty="0"/>
           </a:p>
@@ -3453,7 +3453,7 @@
             <a:r>
               <a:rPr lang="en-US" dirty="0"/>
               <a:t>[11:53 – 1 min] Porta-voz Grupu 5 aprezenta. Hafoin, agradese no aumenta ideia ida se presiza.
-Resposta ezemplu: (1) Hakerek relatóriu fulan, tradús dokumentu, responde pergunta komunidade kona-ba direitu rai, buka kazu hanesan. (2) Ko'alia ho komunidade, komprende kultura no konflitu, foti desizaun, verifika loos ka lae, akompaña iha terrenu. (3) Dadus iha servidór rasik RbR; la fahe naran ema la ho konsentimentu; ema sempre verifika rezultadu AI; asesu tuir papél.</a:t>
+Resposta ezemplu: (1) Hakerek rascunho relatóriu no proposta, tradús Tetun/Portugés/Inglés, rezume dokumentu naruk, ajuda hakerek fórmula Excel ka kódigu Python. (2) Ko'alia ho komunidade, komprende kultura no kontestu, foti desizaun, verifika loos ka lae, responsabilidade étika. (3) Keta tau naran/dadus pesoál iha AI públiku; ema sempre verifika rezultadu; konsentimentu; organizasaun iha polítika uza AI.</a:t>
             </a:r>
             <a:endParaRPr lang="en-US" dirty="0"/>
           </a:p>
@@ -26698,7 +26698,7 @@
                 <a:ea typeface="Cambria" pitchFamily="34" charset="-122"/>
                 <a:cs typeface="Cambria" pitchFamily="34" charset="-120"/>
               </a:rPr>
-              <a:t>Ema hotu ko'alia. La iha resposta sala. Uza ezemplu husi imi-nia servisu iha Rede ba Rai.</a:t>
+              <a:t>Ema hotu ko'alia. La iha resposta sala. Uza ezemplu husi imi-nia servisu iha imi-nia organizasaun.</a:t>
             </a:r>
             <a:endParaRPr lang="en-US" sz="2000" dirty="0"/>
           </a:p>
@@ -27475,7 +27475,7 @@
                   <a:schemeClr val="tx2"/>
                 </a:solidFill>
               </a:rPr>
-              <a:t>Dadus RbR: uluk no agora</a:t>
+              <a:t>Dadus iha organizasaun</a:t>
             </a:r>
             <a:endParaRPr lang="en-US" sz="1600" dirty="0"/>
           </a:p>
@@ -27511,7 +27511,7 @@
                   <a:schemeClr val="tx1"/>
                 </a:solidFill>
               </a:rPr>
-              <a:t>Iha tempu surat, Word no Excel: problema saida mak imi hasoru?</a:t>
+              <a:t>Imi-nia organizasaun rai dadus oinsá agora (papél, Excel, Google Sheets)? Problema boot liu saida?</a:t>
             </a:r>
             <a:endParaRPr lang="en-US" sz="1300" dirty="0"/>
           </a:p>
@@ -27725,7 +27725,7 @@
                   <a:schemeClr val="tx1"/>
                 </a:solidFill>
               </a:rPr>
-              <a:t>Númeru ida-ne'ebé iha Live Dashboard mak importante liu ba advokasia? Tanba sá?</a:t>
+              <a:t>Númeru saida mak doadór ka governu husu beibeik ba imi? Oinsá halo lalais?</a:t>
             </a:r>
             <a:endParaRPr lang="en-US" sz="1300" dirty="0"/>
           </a:p>
@@ -27939,7 +27939,7 @@
                   <a:schemeClr val="tx1"/>
                 </a:solidFill>
               </a:rPr>
-              <a:t>Se RbR iha ajente AI, servisu ida-ne'ebé imi hakarak AI ajuda?</a:t>
+              <a:t>AI (ChatGPT, Claude, Gemini) bele ajuda imi-nia servisu iha saida?</a:t>
             </a:r>
             <a:endParaRPr lang="en-US" sz="1300" dirty="0"/>
           </a:p>
@@ -28575,7 +28575,7 @@
                 <a:ea typeface="Courier New" pitchFamily="34" charset="-122"/>
                 <a:cs typeface="Courier New" pitchFamily="34" charset="-120"/>
               </a:rPr>
-              <a:t>if eviksaun == "Sin":</a:t>
+              <a:t>if partisipante &gt; 30:</a:t>
             </a:r>
             <a:endParaRPr lang="en-US" sz="1400" dirty="0"/>
           </a:p>
@@ -28592,7 +28592,7 @@
                 <a:ea typeface="Courier New" pitchFamily="34" charset="-122"/>
                 <a:cs typeface="Courier New" pitchFamily="34" charset="-120"/>
               </a:rPr>
-              <a:t>    print("Kazu urjente!")</a:t>
+              <a:t>    print("Sala la to'o!")</a:t>
             </a:r>
             <a:endParaRPr lang="en-US" sz="1400" dirty="0"/>
           </a:p>
@@ -28716,7 +28716,7 @@
                   <a:schemeClr val="tx2"/>
                 </a:solidFill>
               </a:rPr>
-              <a:t>Servisu ida iha RbR ne'ebé imi halo fali beibeik ho liman. Python bele ajuda oinsá?</a:t>
+              <a:t>Servisu ida iha imi-nia organizasaun ne'ebé halo fali beibeik ho liman. Python bele ajuda oinsá?</a:t>
             </a:r>
             <a:endParaRPr lang="en-US" sz="1800" dirty="0"/>
           </a:p>
@@ -29286,7 +29286,7 @@
                   <a:schemeClr val="tx2"/>
                 </a:solidFill>
               </a:rPr>
-              <a:t>Guido hahú Python iha feriadu Natál hanesan projetu ki'ik. Lisaun saida ba ita?</a:t>
+              <a:t>Guido hahú Python hanesan projetu ki'ik iha feriadu. Ideia ki'ik saida iha imi-nia organizasaun bele sai boot?</a:t>
             </a:r>
             <a:endParaRPr lang="en-US" sz="1800" dirty="0"/>
           </a:p>
@@ -29410,7 +29410,7 @@
                   <a:schemeClr val="tx2"/>
                 </a:solidFill>
               </a:rPr>
-              <a:t>Python gratuitu no komunidade mundu mak kuida. Tanba sá ida-ne'e importante ba RbR?</a:t>
+              <a:t>Python gratuitu (open source). Vantajen saida ba ONG ho orsamentu ki'ik?</a:t>
             </a:r>
             <a:endParaRPr lang="en-US" sz="1800" dirty="0"/>
           </a:p>
@@ -29518,7 +29518,7 @@
                   <a:schemeClr val="tx2"/>
                 </a:solidFill>
               </a:rPr>
-              <a:t>Grupu 3: Dadus RbR: uluk no agora</a:t>
+              <a:t>Grupu 3: Dadus iha organizasaun</a:t>
             </a:r>
             <a:endParaRPr lang="en-US" sz="3000" dirty="0"/>
           </a:p>
@@ -29732,7 +29732,7 @@
                   <a:schemeClr val="bg1"/>
                 </a:solidFill>
               </a:rPr>
-              <a:t>Dadus RbR: uluk no agora</a:t>
+              <a:t>Dadus iha organizasaun</a:t>
             </a:r>
             <a:endParaRPr lang="en-US" sz="1600" dirty="0"/>
           </a:p>
@@ -29856,7 +29856,7 @@
                   <a:schemeClr val="tx2"/>
                 </a:solidFill>
               </a:rPr>
-              <a:t>Iha tempu surat, Word no Excel: problema saida mak imi hasoru?</a:t>
+              <a:t>Imi-nia organizasaun rai dadus oinsá agora (papél, Excel, Google Sheets)? Problema boot liu saida?</a:t>
             </a:r>
             <a:endParaRPr lang="en-US" sz="1800" dirty="0"/>
           </a:p>
@@ -29980,7 +29980,7 @@
                   <a:schemeClr val="tx2"/>
                 </a:solidFill>
               </a:rPr>
-              <a:t>Saida mak muda iha imi-nia servisu ho SIBAR-RbR? Buat ida di'ak no buat ida susar.</a:t>
+              <a:t>Dadus saida mak imi rekolla, maibé la uza di'ak?</a:t>
             </a:r>
             <a:endParaRPr lang="en-US" sz="1800" dirty="0"/>
           </a:p>
@@ -30104,7 +30104,7 @@
                   <a:schemeClr val="tx2"/>
                 </a:solidFill>
               </a:rPr>
-              <a:t>Se kazu eviksaun ida rejista dala rua, saida mak bele akontese ba relatóriu no advokasia?</a:t>
+              <a:t>Se organizasaun barak (KSI, FONGTIL, RbR...) fahe dadus, benefísiu no risku saida?</a:t>
             </a:r>
             <a:endParaRPr lang="en-US" sz="1800" dirty="0"/>
           </a:p>
@@ -30550,7 +30550,7 @@
                   <a:schemeClr val="tx2"/>
                 </a:solidFill>
               </a:rPr>
-              <a:t>Númeru ida-ne'ebé iha Live Dashboard mak importante liu ba advokasia? Tanba sá?</a:t>
+              <a:t>Númeru saida mak doadór ka governu husu beibeik ba imi? Oinsá halo lalais?</a:t>
             </a:r>
             <a:endParaRPr lang="en-US" sz="1800" dirty="0"/>
           </a:p>
@@ -30674,7 +30674,7 @@
                   <a:schemeClr val="tx2"/>
                 </a:solidFill>
               </a:rPr>
-              <a:t>Se imi bele husu Python atu konta buat ida, saida mak imi hakarak hatene?</a:t>
+              <a:t>Gráfiku ka mapa ida ne'ebé sei ajuda imi-nia advokasia?</a:t>
             </a:r>
             <a:endParaRPr lang="en-US" sz="1800" dirty="0"/>
           </a:p>
@@ -30798,7 +30798,7 @@
                   <a:schemeClr val="tx2"/>
                 </a:solidFill>
               </a:rPr>
-              <a:t>Oinsá dadus kazu eviksaun bele ajuda komunidade afetadu duni?</a:t>
+              <a:t>Oinsá dadus bele ajuda komunidade duni, la'ós de'it ba relatóriu?</a:t>
             </a:r>
             <a:endParaRPr lang="en-US" sz="1800" dirty="0"/>
           </a:p>
@@ -31244,7 +31244,7 @@
                   <a:schemeClr val="tx2"/>
                 </a:solidFill>
               </a:rPr>
-              <a:t>Se RbR iha ajente AI, servisu ida-ne'ebé imi hakarak AI ajuda?</a:t>
+              <a:t>AI (ChatGPT, Claude, Gemini) bele ajuda imi-nia servisu iha saida?</a:t>
             </a:r>
             <a:endParaRPr lang="en-US" sz="1800" dirty="0"/>
           </a:p>
@@ -31492,7 +31492,7 @@
                   <a:schemeClr val="tx2"/>
                 </a:solidFill>
               </a:rPr>
-              <a:t>Dadus komunidade sensível: regra saida mak tenke iha bainhira uza AI?</a:t>
+              <a:t>Regra saida mak organizasaun tenke iha bainhira uza AI ho dadus komunidade?</a:t>
             </a:r>
             <a:endParaRPr lang="en-US" sz="1800" dirty="0"/>
           </a:p>

</xml_diff>